<commit_message>
Rename app to "Anshi German Learning App"
Title, header, manifest (home-screen label "Anshi German"), README,
DEPLOY.md and the slide deck. Cache version bumped so installed apps update.

Co-Authored-By: Claude Opus 5.5 <noreply@anthropic.com>
</commit_message>
<xml_diff>
--- a/docs/Artikel-Trainer-Licensing-and-Mobile-App.pptx
+++ b/docs/Artikel-Trainer-Licensing-and-Mobile-App.pptx
@@ -4408,17 +4408,17 @@
           <a:p>
             <a:pPr algn="l">
               <a:spcAft>
-                <a:spcPts val="2100"/>
+                <a:spcPts val="1679"/>
               </a:spcAft>
             </a:pPr>
             <a:r>
-              <a:rPr sz="6000" b="1">
+              <a:rPr sz="4800" b="1">
                 <a:solidFill>
                   <a:srgbClr val="FBFBF8"/>
                 </a:solidFill>
                 <a:latin typeface="Calibri"/>
               </a:rPr>
-              <a:t>Artikel-Trainer</a:t>
+              <a:t>Anshi German Learning App</a:t>
             </a:r>
           </a:p>
           <a:p>
@@ -6501,7 +6501,7 @@
                 </a:solidFill>
                 <a:latin typeface="Calibri"/>
               </a:rPr>
-              <a:t>Keep "Artikel-Trainer" or pick a distinctive one.</a:t>
+              <a:t>Decided: "Anshi German Learning App".</a:t>
             </a:r>
           </a:p>
         </p:txBody>
@@ -9317,7 +9317,7 @@
                 </a:solidFill>
                 <a:latin typeface="Calibri"/>
               </a:rPr>
-              <a:t>"Artikel-Trainer" is generic; search the stores first.</a:t>
+              <a:t>Search the stores for "Anshi German Learning App" first.</a:t>
             </a:r>
           </a:p>
         </p:txBody>

</xml_diff>